<commit_message>
Cierre de tareas finales del proyecto y preparación de la versión de entrega
- Finalización de la documentación pendiente del proyecto.
- Actualización y reorganización de los materiales de apoyo para la guía de usuario.
- Revisión final de la presentación del TFG.
- Resubida y actualización del fichero Zotero con las referencias bibliográficas empleadas.
- Corrección de incidencias detectadas en el flujo de recuento de votaciones.
- Ajuste de los procesos de descifrado y validación criptográfica de votos.
- Corrección de la visualización de resultados y candidatura ganadora en la interfaz de mesa electoral.
- Revisión general y estabilización de la aplicación previa a la generación de la versión final.

Closes #1
Closes #38
Closes #42
Closes #43
</commit_message>
<xml_diff>
--- a/DocumentosTFG/PresentaciónTFG.pptx
+++ b/DocumentosTFG/PresentaciónTFG.pptx
@@ -414,6 +414,27 @@
 </p188:cmLst>
 </file>
 
+<file path=ppt/comments/modernComment_10F_687EE0A8.xml><?xml version="1.0" encoding="utf-8"?>
+<p188:cmLst xmlns:a="http://schemas.openxmlformats.org/drawingml/2006/main" xmlns:r="http://schemas.openxmlformats.org/officeDocument/2006/relationships" xmlns:p188="http://schemas.microsoft.com/office/powerpoint/2018/8/main">
+  <p188:cm id="{697D629B-86C2-4A2D-B1FA-2BBEC1B35DD1}" authorId="{D46F2EB9-8792-1B5E-E482-6287A72B49A3}" created="2026-06-10T21:19:01.275">
+    <pc:sldMkLst xmlns:pc="http://schemas.microsoft.com/office/powerpoint/2013/main/command">
+      <pc:docMk/>
+      <pc:sldMk cId="1753145512" sldId="271"/>
+    </pc:sldMkLst>
+    <p188:txBody>
+      <a:bodyPr/>
+      <a:lstStyle/>
+      <a:p>
+        <a:r>
+          <a:rPr lang="es-ES"/>
+          <a:t>El usuario previamente a una votación configura su certificado para poder acceder a la votación seleccionada en la que puede participar. Después elige la candidatura a la cual quiere votar y firma y envía su voto</a:t>
+        </a:r>
+      </a:p>
+    </p188:txBody>
+  </p188:cm>
+</p188:cmLst>
+</file>
+
 <file path=ppt/comments/modernComment_110_3FD3B5C.xml><?xml version="1.0" encoding="utf-8"?>
 <p188:cmLst xmlns:a="http://schemas.openxmlformats.org/drawingml/2006/main" xmlns:r="http://schemas.openxmlformats.org/officeDocument/2006/relationships" xmlns:p188="http://schemas.microsoft.com/office/powerpoint/2018/8/main">
   <p188:cm id="{E297E20B-3E96-4486-AD97-77BF88A36A3A}" authorId="{D46F2EB9-8792-1B5E-E482-6287A72B49A3}" created="2026-06-06T18:45:45.837">
@@ -517,7 +538,7 @@
           <a:p>
             <a:fld id="{F033DA4F-E9E2-486B-9E28-2A3AE3321793}" type="datetimeFigureOut">
               <a:rPr lang="es-ES" smtClean="0"/>
-              <a:t>07/06/2026</a:t>
+              <a:t>11/06/2026</a:t>
             </a:fld>
             <a:endParaRPr lang="es-ES"/>
           </a:p>
@@ -1113,7 +1134,7 @@
           <a:p>
             <a:fld id="{0082298D-10ED-4CEA-ABC9-062C01423615}" type="datetimeFigureOut">
               <a:rPr lang="es-ES" smtClean="0"/>
-              <a:t>07/06/2026</a:t>
+              <a:t>11/06/2026</a:t>
             </a:fld>
             <a:endParaRPr lang="es-ES"/>
           </a:p>
@@ -1311,7 +1332,7 @@
           <a:p>
             <a:fld id="{0082298D-10ED-4CEA-ABC9-062C01423615}" type="datetimeFigureOut">
               <a:rPr lang="es-ES" smtClean="0"/>
-              <a:t>07/06/2026</a:t>
+              <a:t>11/06/2026</a:t>
             </a:fld>
             <a:endParaRPr lang="es-ES"/>
           </a:p>
@@ -1519,7 +1540,7 @@
           <a:p>
             <a:fld id="{0082298D-10ED-4CEA-ABC9-062C01423615}" type="datetimeFigureOut">
               <a:rPr lang="es-ES" smtClean="0"/>
-              <a:t>07/06/2026</a:t>
+              <a:t>11/06/2026</a:t>
             </a:fld>
             <a:endParaRPr lang="es-ES"/>
           </a:p>
@@ -1717,7 +1738,7 @@
           <a:p>
             <a:fld id="{0082298D-10ED-4CEA-ABC9-062C01423615}" type="datetimeFigureOut">
               <a:rPr lang="es-ES" smtClean="0"/>
-              <a:t>07/06/2026</a:t>
+              <a:t>11/06/2026</a:t>
             </a:fld>
             <a:endParaRPr lang="es-ES"/>
           </a:p>
@@ -1992,7 +2013,7 @@
           <a:p>
             <a:fld id="{0082298D-10ED-4CEA-ABC9-062C01423615}" type="datetimeFigureOut">
               <a:rPr lang="es-ES" smtClean="0"/>
-              <a:t>07/06/2026</a:t>
+              <a:t>11/06/2026</a:t>
             </a:fld>
             <a:endParaRPr lang="es-ES"/>
           </a:p>
@@ -2257,7 +2278,7 @@
           <a:p>
             <a:fld id="{0082298D-10ED-4CEA-ABC9-062C01423615}" type="datetimeFigureOut">
               <a:rPr lang="es-ES" smtClean="0"/>
-              <a:t>07/06/2026</a:t>
+              <a:t>11/06/2026</a:t>
             </a:fld>
             <a:endParaRPr lang="es-ES"/>
           </a:p>
@@ -2669,7 +2690,7 @@
           <a:p>
             <a:fld id="{0082298D-10ED-4CEA-ABC9-062C01423615}" type="datetimeFigureOut">
               <a:rPr lang="es-ES" smtClean="0"/>
-              <a:t>07/06/2026</a:t>
+              <a:t>11/06/2026</a:t>
             </a:fld>
             <a:endParaRPr lang="es-ES"/>
           </a:p>
@@ -2810,7 +2831,7 @@
           <a:p>
             <a:fld id="{0082298D-10ED-4CEA-ABC9-062C01423615}" type="datetimeFigureOut">
               <a:rPr lang="es-ES" smtClean="0"/>
-              <a:t>07/06/2026</a:t>
+              <a:t>11/06/2026</a:t>
             </a:fld>
             <a:endParaRPr lang="es-ES"/>
           </a:p>
@@ -2923,7 +2944,7 @@
           <a:p>
             <a:fld id="{0082298D-10ED-4CEA-ABC9-062C01423615}" type="datetimeFigureOut">
               <a:rPr lang="es-ES" smtClean="0"/>
-              <a:t>07/06/2026</a:t>
+              <a:t>11/06/2026</a:t>
             </a:fld>
             <a:endParaRPr lang="es-ES"/>
           </a:p>
@@ -3234,7 +3255,7 @@
           <a:p>
             <a:fld id="{0082298D-10ED-4CEA-ABC9-062C01423615}" type="datetimeFigureOut">
               <a:rPr lang="es-ES" smtClean="0"/>
-              <a:t>07/06/2026</a:t>
+              <a:t>11/06/2026</a:t>
             </a:fld>
             <a:endParaRPr lang="es-ES"/>
           </a:p>
@@ -3522,7 +3543,7 @@
           <a:p>
             <a:fld id="{0082298D-10ED-4CEA-ABC9-062C01423615}" type="datetimeFigureOut">
               <a:rPr lang="es-ES" smtClean="0"/>
-              <a:t>07/06/2026</a:t>
+              <a:t>11/06/2026</a:t>
             </a:fld>
             <a:endParaRPr lang="es-ES"/>
           </a:p>
@@ -3763,7 +3784,7 @@
           <a:p>
             <a:fld id="{0082298D-10ED-4CEA-ABC9-062C01423615}" type="datetimeFigureOut">
               <a:rPr lang="es-ES" smtClean="0"/>
-              <a:t>07/06/2026</a:t>
+              <a:t>11/06/2026</a:t>
             </a:fld>
             <a:endParaRPr lang="es-ES"/>
           </a:p>
@@ -6044,6 +6065,173 @@
           </a:p>
         </p:txBody>
       </p:sp>
+      <p:pic>
+        <p:nvPicPr>
+          <p:cNvPr id="8" name="Imagen 7">
+            <a:extLst>
+              <a:ext uri="{FF2B5EF4-FFF2-40B4-BE49-F238E27FC236}">
+                <a16:creationId xmlns:a16="http://schemas.microsoft.com/office/drawing/2014/main" id="{8C6EB7B6-EF7B-9F01-8876-C4868E874E58}"/>
+              </a:ext>
+            </a:extLst>
+          </p:cNvPr>
+          <p:cNvPicPr>
+            <a:picLocks noChangeAspect="1"/>
+          </p:cNvPicPr>
+          <p:nvPr/>
+        </p:nvPicPr>
+        <p:blipFill>
+          <a:blip r:embed="rId3"/>
+          <a:stretch>
+            <a:fillRect/>
+          </a:stretch>
+        </p:blipFill>
+        <p:spPr>
+          <a:xfrm>
+            <a:off x="465940" y="1680983"/>
+            <a:ext cx="4791274" cy="1828143"/>
+          </a:xfrm>
+          <a:prstGeom prst="rect">
+            <a:avLst/>
+          </a:prstGeom>
+        </p:spPr>
+      </p:pic>
+      <p:pic>
+        <p:nvPicPr>
+          <p:cNvPr id="10" name="Imagen 9">
+            <a:extLst>
+              <a:ext uri="{FF2B5EF4-FFF2-40B4-BE49-F238E27FC236}">
+                <a16:creationId xmlns:a16="http://schemas.microsoft.com/office/drawing/2014/main" id="{BD8CBC2F-771D-9A14-E47F-458BEB6567C3}"/>
+              </a:ext>
+            </a:extLst>
+          </p:cNvPr>
+          <p:cNvPicPr>
+            <a:picLocks noChangeAspect="1"/>
+          </p:cNvPicPr>
+          <p:nvPr/>
+        </p:nvPicPr>
+        <p:blipFill>
+          <a:blip r:embed="rId4"/>
+          <a:stretch>
+            <a:fillRect/>
+          </a:stretch>
+        </p:blipFill>
+        <p:spPr>
+          <a:xfrm>
+            <a:off x="6934788" y="1737352"/>
+            <a:ext cx="4791272" cy="2022711"/>
+          </a:xfrm>
+          <a:prstGeom prst="rect">
+            <a:avLst/>
+          </a:prstGeom>
+        </p:spPr>
+      </p:pic>
+      <p:pic>
+        <p:nvPicPr>
+          <p:cNvPr id="12" name="Imagen 11">
+            <a:extLst>
+              <a:ext uri="{FF2B5EF4-FFF2-40B4-BE49-F238E27FC236}">
+                <a16:creationId xmlns:a16="http://schemas.microsoft.com/office/drawing/2014/main" id="{0ED724EC-C954-26BF-9BF9-A28892E77637}"/>
+              </a:ext>
+            </a:extLst>
+          </p:cNvPr>
+          <p:cNvPicPr>
+            <a:picLocks noChangeAspect="1"/>
+          </p:cNvPicPr>
+          <p:nvPr/>
+        </p:nvPicPr>
+        <p:blipFill>
+          <a:blip r:embed="rId5"/>
+          <a:stretch>
+            <a:fillRect/>
+          </a:stretch>
+        </p:blipFill>
+        <p:spPr>
+          <a:xfrm>
+            <a:off x="1178789" y="3695411"/>
+            <a:ext cx="3809540" cy="2265132"/>
+          </a:xfrm>
+          <a:prstGeom prst="rect">
+            <a:avLst/>
+          </a:prstGeom>
+        </p:spPr>
+      </p:pic>
+      <p:sp>
+        <p:nvSpPr>
+          <p:cNvPr id="13" name="CuadroTexto 12">
+            <a:extLst>
+              <a:ext uri="{FF2B5EF4-FFF2-40B4-BE49-F238E27FC236}">
+                <a16:creationId xmlns:a16="http://schemas.microsoft.com/office/drawing/2014/main" id="{2D6CB3A4-C5B7-4498-5957-13643EBFDCAC}"/>
+              </a:ext>
+            </a:extLst>
+          </p:cNvPr>
+          <p:cNvSpPr txBox="1"/>
+          <p:nvPr/>
+        </p:nvSpPr>
+        <p:spPr>
+          <a:xfrm>
+            <a:off x="5861304" y="4143543"/>
+            <a:ext cx="4636008" cy="954107"/>
+          </a:xfrm>
+          <a:prstGeom prst="rect">
+            <a:avLst/>
+          </a:prstGeom>
+          <a:noFill/>
+        </p:spPr>
+        <p:txBody>
+          <a:bodyPr wrap="square" rtlCol="0">
+            <a:spAutoFit/>
+          </a:bodyPr>
+          <a:lstStyle/>
+          <a:p>
+            <a:pPr marL="285750" indent="-285750">
+              <a:buFont typeface="Arial" panose="020B0604020202020204" pitchFamily="34" charset="0"/>
+              <a:buChar char="•"/>
+            </a:pPr>
+            <a:r>
+              <a:rPr lang="es-ES" sz="1400" dirty="0">
+                <a:latin typeface="Aptos" panose="020B0004020202020204" pitchFamily="34" charset="0"/>
+              </a:rPr>
+              <a:t>Configuración de su certificado</a:t>
+            </a:r>
+          </a:p>
+          <a:p>
+            <a:pPr marL="285750" indent="-285750">
+              <a:buFont typeface="Arial" panose="020B0604020202020204" pitchFamily="34" charset="0"/>
+              <a:buChar char="•"/>
+            </a:pPr>
+            <a:r>
+              <a:rPr lang="es-ES" sz="1400" dirty="0">
+                <a:latin typeface="Aptos" panose="020B0004020202020204" pitchFamily="34" charset="0"/>
+              </a:rPr>
+              <a:t>Selección de la votación</a:t>
+            </a:r>
+          </a:p>
+          <a:p>
+            <a:pPr marL="285750" indent="-285750">
+              <a:buFont typeface="Arial" panose="020B0604020202020204" pitchFamily="34" charset="0"/>
+              <a:buChar char="•"/>
+            </a:pPr>
+            <a:r>
+              <a:rPr lang="es-ES" sz="1400" dirty="0">
+                <a:latin typeface="Aptos" panose="020B0004020202020204" pitchFamily="34" charset="0"/>
+              </a:rPr>
+              <a:t>Selección de candidatura</a:t>
+            </a:r>
+          </a:p>
+          <a:p>
+            <a:pPr marL="285750" indent="-285750">
+              <a:buFont typeface="Arial" panose="020B0604020202020204" pitchFamily="34" charset="0"/>
+              <a:buChar char="•"/>
+            </a:pPr>
+            <a:r>
+              <a:rPr lang="es-ES" sz="1400" dirty="0">
+                <a:latin typeface="Aptos" panose="020B0004020202020204" pitchFamily="34" charset="0"/>
+              </a:rPr>
+              <a:t>Emisión del voto</a:t>
+            </a:r>
+          </a:p>
+        </p:txBody>
+      </p:sp>
     </p:spTree>
     <p:extLst>
       <p:ext uri="{BB962C8B-B14F-4D97-AF65-F5344CB8AC3E}">
@@ -6054,6 +6242,11 @@
   <p:clrMapOvr>
     <a:masterClrMapping/>
   </p:clrMapOvr>
+  <p:extLst>
+    <p:ext uri="{6950BFC3-D8DA-4A85-94F7-54DA5524770B}">
+      <p188:commentRel xmlns:p188="http://schemas.microsoft.com/office/powerpoint/2018/8/main" r:id="rId2"/>
+    </p:ext>
+  </p:extLst>
 </p:sld>
 </file>
 
@@ -6279,10 +6472,10 @@
       </p:sp>
       <p:pic>
         <p:nvPicPr>
-          <p:cNvPr id="9" name="Imagen 8">
-            <a:extLst>
-              <a:ext uri="{FF2B5EF4-FFF2-40B4-BE49-F238E27FC236}">
-                <a16:creationId xmlns:a16="http://schemas.microsoft.com/office/drawing/2014/main" id="{44050D42-AAB6-AFC0-8C0B-711A471E9362}"/>
+          <p:cNvPr id="13" name="Imagen 12">
+            <a:extLst>
+              <a:ext uri="{FF2B5EF4-FFF2-40B4-BE49-F238E27FC236}">
+                <a16:creationId xmlns:a16="http://schemas.microsoft.com/office/drawing/2014/main" id="{872ECD64-85CE-43B7-8CA7-30BD5FA830F0}"/>
               </a:ext>
             </a:extLst>
           </p:cNvPr>
@@ -6299,8 +6492,8 @@
         </p:blipFill>
         <p:spPr>
           <a:xfrm>
-            <a:off x="6096000" y="1690187"/>
-            <a:ext cx="5876704" cy="2150167"/>
+            <a:off x="498444" y="1690187"/>
+            <a:ext cx="5428250" cy="4139753"/>
           </a:xfrm>
           <a:prstGeom prst="rect">
             <a:avLst/>
@@ -6309,10 +6502,10 @@
       </p:pic>
       <p:pic>
         <p:nvPicPr>
-          <p:cNvPr id="13" name="Imagen 12">
-            <a:extLst>
-              <a:ext uri="{FF2B5EF4-FFF2-40B4-BE49-F238E27FC236}">
-                <a16:creationId xmlns:a16="http://schemas.microsoft.com/office/drawing/2014/main" id="{872ECD64-85CE-43B7-8CA7-30BD5FA830F0}"/>
+          <p:cNvPr id="8" name="Imagen 7">
+            <a:extLst>
+              <a:ext uri="{FF2B5EF4-FFF2-40B4-BE49-F238E27FC236}">
+                <a16:creationId xmlns:a16="http://schemas.microsoft.com/office/drawing/2014/main" id="{A555D0C2-72D9-8DEE-A92C-EF5B37F59166}"/>
               </a:ext>
             </a:extLst>
           </p:cNvPr>
@@ -6329,8 +6522,38 @@
         </p:blipFill>
         <p:spPr>
           <a:xfrm>
-            <a:off x="498444" y="1690187"/>
-            <a:ext cx="5428250" cy="4139753"/>
+            <a:off x="7376062" y="1625534"/>
+            <a:ext cx="4127090" cy="1558702"/>
+          </a:xfrm>
+          <a:prstGeom prst="rect">
+            <a:avLst/>
+          </a:prstGeom>
+        </p:spPr>
+      </p:pic>
+      <p:pic>
+        <p:nvPicPr>
+          <p:cNvPr id="11" name="Imagen 10">
+            <a:extLst>
+              <a:ext uri="{FF2B5EF4-FFF2-40B4-BE49-F238E27FC236}">
+                <a16:creationId xmlns:a16="http://schemas.microsoft.com/office/drawing/2014/main" id="{0AEA62AF-4A3E-191C-F156-C33A5792D2A6}"/>
+              </a:ext>
+            </a:extLst>
+          </p:cNvPr>
+          <p:cNvPicPr>
+            <a:picLocks noChangeAspect="1"/>
+          </p:cNvPicPr>
+          <p:nvPr/>
+        </p:nvPicPr>
+        <p:blipFill>
+          <a:blip r:embed="rId5"/>
+          <a:stretch>
+            <a:fillRect/>
+          </a:stretch>
+        </p:blipFill>
+        <p:spPr>
+          <a:xfrm>
+            <a:off x="7376062" y="3429000"/>
+            <a:ext cx="4127091" cy="1647050"/>
           </a:xfrm>
           <a:prstGeom prst="rect">
             <a:avLst/>

</xml_diff>

<commit_message>
Finalización de la memoria del TFG y revisión documental
- Migración completa de la memoria principal a la plantilla LaTeX definitiva.
- Reestructuración y revisión completa de los capítulos del documento.
- Incorporación y actualización de figuras, tablas y referencias bibliográficas.
- Revisión de la bibliografía mediante Zotero y adaptación de las citas al nuevo formato.
- Revisión del estudio económico y del apartado de sostenibilización curricular.
- Corrección de estilo, maquetación y referencias cruzadas de la memoria.

Closes #44
Closes #45
</commit_message>
<xml_diff>
--- a/DocumentosTFG/PresentaciónTFG.pptx
+++ b/DocumentosTFG/PresentaciónTFG.pptx
@@ -7109,7 +7109,7 @@
             <a:pPr algn="ctr"/>
             <a:r>
               <a:rPr lang="es-ES" u="sng" dirty="0"/>
-              <a:t>LINEAS DE TRABAJO</a:t>
+              <a:t>LÍNEAS DE TRABAJO</a:t>
             </a:r>
           </a:p>
           <a:p>
@@ -7173,7 +7173,7 @@
             </a:r>
             <a:r>
               <a:rPr lang="es-ES" sz="1600" dirty="0"/>
-              <a:t>(no hay integración son sistemas externos de identidad o directorios)</a:t>
+              <a:t>(no hay integración con sistemas externos de identidad o directorios)</a:t>
             </a:r>
           </a:p>
           <a:p>
@@ -13967,7 +13967,7 @@
                   <a:schemeClr val="bg1"/>
                 </a:solidFill>
               </a:rPr>
-              <a:t>TECNOLOGIAS USADAS</a:t>
+              <a:t>TECNOLOGÍAS USADAS</a:t>
             </a:r>
           </a:p>
         </p:txBody>
@@ -14810,7 +14810,7 @@
             <a:pPr algn="ctr"/>
             <a:r>
               <a:rPr lang="es-ES" dirty="0"/>
-              <a:t>HMTL | CSS | JS</a:t>
+              <a:t>HTML | CSS | JS</a:t>
             </a:r>
           </a:p>
         </p:txBody>
@@ -14889,7 +14889,7 @@
             <a:pPr algn="ctr"/>
             <a:r>
               <a:rPr lang="es-ES" u="sng" dirty="0"/>
-              <a:t>X.059</a:t>
+              <a:t>X.509</a:t>
             </a:r>
           </a:p>
           <a:p>

</xml_diff>